<commit_message>
fix: regenerate blank otp_trend figure and rebuild deck slide 5
Co-Authored-By: Claude Fable 5 <noreply@anthropic.com>
</commit_message>
<xml_diff>
--- a/reports/final_presentation.pptx
+++ b/reports/final_presentation.pptx
@@ -8908,8 +8908,8 @@
         </p:nvSpPr>
         <p:spPr>
           <a:xfrm>
-            <a:off x="969264" y="1689354"/>
-            <a:ext cx="5102352" cy="3845052"/>
+            <a:off x="466344" y="1742221"/>
+            <a:ext cx="6108192" cy="3922197"/>
           </a:xfrm>
           <a:prstGeom prst="rect">
             <a:avLst/>
@@ -8962,8 +8962,8 @@
         </p:blipFill>
         <p:spPr>
           <a:xfrm>
-            <a:off x="1005840" y="1725930"/>
-            <a:ext cx="5029200" cy="3771900"/>
+            <a:off x="502920" y="1778797"/>
+            <a:ext cx="6035040" cy="3849045"/>
           </a:xfrm>
           <a:prstGeom prst="rect">
             <a:avLst/>

</xml_diff>